<commit_message>
feat(content): add plotly exercises and GETTING_START document for plotly
</commit_message>
<xml_diff>
--- a/0-plotly-python/MyNote.pptx
+++ b/0-plotly-python/MyNote.pptx
@@ -6,41 +6,42 @@
   </p:sldMasterIdLst>
   <p:sldIdLst>
     <p:sldId id="256" r:id="rId2"/>
-    <p:sldId id="260" r:id="rId3"/>
-    <p:sldId id="264" r:id="rId4"/>
+    <p:sldId id="264" r:id="rId3"/>
+    <p:sldId id="260" r:id="rId4"/>
     <p:sldId id="257" r:id="rId5"/>
     <p:sldId id="259" r:id="rId6"/>
     <p:sldId id="258" r:id="rId7"/>
     <p:sldId id="261" r:id="rId8"/>
     <p:sldId id="262" r:id="rId9"/>
     <p:sldId id="263" r:id="rId10"/>
+    <p:sldId id="265" r:id="rId11"/>
   </p:sldIdLst>
   <p:sldSz cx="12192000" cy="6858000"/>
   <p:notesSz cx="6858000" cy="9144000"/>
   <p:embeddedFontLst>
     <p:embeddedFont>
       <p:font typeface="Anuphan" pitchFamily="2" charset="-34"/>
-      <p:regular r:id="rId11"/>
-      <p:bold r:id="rId12"/>
+      <p:regular r:id="rId12"/>
+      <p:bold r:id="rId13"/>
     </p:embeddedFont>
     <p:embeddedFont>
       <p:font typeface="Consolas" panose="020B0609020204030204" pitchFamily="49" charset="0"/>
-      <p:regular r:id="rId13"/>
-      <p:bold r:id="rId14"/>
-      <p:italic r:id="rId15"/>
-      <p:boldItalic r:id="rId16"/>
+      <p:regular r:id="rId14"/>
+      <p:bold r:id="rId15"/>
+      <p:italic r:id="rId16"/>
+      <p:boldItalic r:id="rId17"/>
     </p:embeddedFont>
     <p:embeddedFont>
       <p:font typeface="dm mono" panose="020B0509040201040103" pitchFamily="49" charset="0"/>
-      <p:regular r:id="rId17"/>
-      <p:italic r:id="rId18"/>
+      <p:regular r:id="rId18"/>
+      <p:italic r:id="rId19"/>
     </p:embeddedFont>
     <p:embeddedFont>
       <p:font typeface="Open Sans" panose="020B0606030504020204" pitchFamily="34" charset="0"/>
-      <p:regular r:id="rId19"/>
-      <p:bold r:id="rId20"/>
-      <p:italic r:id="rId21"/>
-      <p:boldItalic r:id="rId22"/>
+      <p:regular r:id="rId20"/>
+      <p:bold r:id="rId21"/>
+      <p:italic r:id="rId22"/>
+      <p:boldItalic r:id="rId23"/>
     </p:embeddedFont>
   </p:embeddedFontLst>
   <p:defaultTextStyle>
@@ -3456,12 +3457,18 @@
 </p:sld>
 </file>
 
-<file path=ppt/slides/slide2.xml><?xml version="1.0" encoding="utf-8"?>
+<file path=ppt/slides/slide10.xml><?xml version="1.0" encoding="utf-8"?>
 <p:sld xmlns:a="http://schemas.openxmlformats.org/drawingml/2006/main" xmlns:r="http://schemas.openxmlformats.org/officeDocument/2006/relationships" xmlns:p="http://schemas.openxmlformats.org/presentationml/2006/main">
   <p:cSld>
     <p:spTree>
       <p:nvGrpSpPr>
-        <p:cNvPr id="1" name=""/>
+        <p:cNvPr id="1" name="">
+          <a:extLst>
+            <a:ext uri="{FF2B5EF4-FFF2-40B4-BE49-F238E27FC236}">
+              <a16:creationId xmlns:a16="http://schemas.microsoft.com/office/drawing/2014/main" id="{77940502-7F1F-8836-34B8-84F3BB178A60}"/>
+            </a:ext>
+          </a:extLst>
+        </p:cNvPr>
         <p:cNvGrpSpPr/>
         <p:nvPr/>
       </p:nvGrpSpPr>
@@ -3478,7 +3485,7 @@
           <p:cNvPr id="5" name="TextBox 4">
             <a:extLst>
               <a:ext uri="{FF2B5EF4-FFF2-40B4-BE49-F238E27FC236}">
-                <a16:creationId xmlns:a16="http://schemas.microsoft.com/office/drawing/2014/main" id="{D848F1C7-F8E2-FBEC-D5A9-269E330446AD}"/>
+                <a16:creationId xmlns:a16="http://schemas.microsoft.com/office/drawing/2014/main" id="{4E859770-4FB1-CA4E-54AE-4E2522C319F1}"/>
               </a:ext>
             </a:extLst>
           </p:cNvPr>
@@ -3488,7 +3495,7 @@
         <p:spPr>
           <a:xfrm>
             <a:off x="1052052" y="3246792"/>
-            <a:ext cx="10087896" cy="769441"/>
+            <a:ext cx="10087896" cy="707886"/>
           </a:xfrm>
           <a:prstGeom prst="rect">
             <a:avLst/>
@@ -3505,7 +3512,7 @@
               <a:buNone/>
             </a:pPr>
             <a:r>
-              <a:rPr lang="en-US" sz="4400" b="1" i="0" dirty="0">
+              <a:rPr lang="en-US" sz="4000" b="1" i="0" dirty="0">
                 <a:solidFill>
                   <a:srgbClr val="20293D"/>
                 </a:solidFill>
@@ -3513,17 +3520,17 @@
                 <a:latin typeface="Anuphan" pitchFamily="2" charset="-34"/>
                 <a:cs typeface="Anuphan" pitchFamily="2" charset="-34"/>
               </a:rPr>
-              <a:t>The Figure Data Structure in Python</a:t>
+              <a:t>Plotly Express</a:t>
             </a:r>
           </a:p>
         </p:txBody>
       </p:sp>
       <p:sp>
         <p:nvSpPr>
-          <p:cNvPr id="7" name="TextBox 6">
+          <p:cNvPr id="3" name="TextBox 2">
             <a:extLst>
               <a:ext uri="{FF2B5EF4-FFF2-40B4-BE49-F238E27FC236}">
-                <a16:creationId xmlns:a16="http://schemas.microsoft.com/office/drawing/2014/main" id="{55DC4C34-2135-4DDF-F881-B2E89B36BA53}"/>
+                <a16:creationId xmlns:a16="http://schemas.microsoft.com/office/drawing/2014/main" id="{DB23362B-AC8E-1708-C907-F91C6AD185CF}"/>
               </a:ext>
             </a:extLst>
           </p:cNvPr>
@@ -3532,8 +3539,8 @@
         </p:nvSpPr>
         <p:spPr>
           <a:xfrm>
-            <a:off x="1052052" y="4016233"/>
-            <a:ext cx="6096000" cy="369332"/>
+            <a:off x="1052052" y="3954678"/>
+            <a:ext cx="9163664" cy="646331"/>
           </a:xfrm>
           <a:prstGeom prst="rect">
             <a:avLst/>
@@ -3547,19 +3554,62 @@
           <a:lstStyle/>
           <a:p>
             <a:r>
+              <a:rPr lang="en-US" dirty="0" err="1">
+                <a:latin typeface="Anuphan" pitchFamily="2" charset="-34"/>
+                <a:cs typeface="Anuphan" pitchFamily="2" charset="-34"/>
+                <a:hlinkClick r:id="rId2"/>
+              </a:rPr>
+              <a:t>plotly.express</a:t>
+            </a:r>
+            <a:r>
               <a:rPr lang="en-US" dirty="0">
+                <a:latin typeface="Anuphan" pitchFamily="2" charset="-34"/>
+                <a:cs typeface="Anuphan" pitchFamily="2" charset="-34"/>
                 <a:hlinkClick r:id="rId2"/>
               </a:rPr>
-              <a:t>The figure data structure in Python</a:t>
-            </a:r>
-            <a:endParaRPr lang="en-US" dirty="0"/>
+              <a:t>: high-level interface for data visualization — 6.6.0 documentation</a:t>
+            </a:r>
+            <a:endParaRPr lang="en-US" dirty="0">
+              <a:latin typeface="Anuphan" pitchFamily="2" charset="-34"/>
+              <a:cs typeface="Anuphan" pitchFamily="2" charset="-34"/>
+            </a:endParaRPr>
+          </a:p>
+          <a:p>
+            <a:r>
+              <a:rPr lang="en-US" dirty="0">
+                <a:latin typeface="Anuphan" pitchFamily="2" charset="-34"/>
+                <a:cs typeface="Anuphan" pitchFamily="2" charset="-34"/>
+                <a:hlinkClick r:id="rId3"/>
+              </a:rPr>
+              <a:t>Python API reference for </a:t>
+            </a:r>
+            <a:r>
+              <a:rPr lang="en-US" dirty="0" err="1">
+                <a:latin typeface="Anuphan" pitchFamily="2" charset="-34"/>
+                <a:cs typeface="Anuphan" pitchFamily="2" charset="-34"/>
+                <a:hlinkClick r:id="rId3"/>
+              </a:rPr>
+              <a:t>plotly</a:t>
+            </a:r>
+            <a:r>
+              <a:rPr lang="en-US" dirty="0">
+                <a:latin typeface="Anuphan" pitchFamily="2" charset="-34"/>
+                <a:cs typeface="Anuphan" pitchFamily="2" charset="-34"/>
+                <a:hlinkClick r:id="rId3"/>
+              </a:rPr>
+              <a:t> — 6.6.0 documentation</a:t>
+            </a:r>
+            <a:endParaRPr lang="en-US" dirty="0">
+              <a:latin typeface="Anuphan" pitchFamily="2" charset="-34"/>
+              <a:cs typeface="Anuphan" pitchFamily="2" charset="-34"/>
+            </a:endParaRPr>
           </a:p>
         </p:txBody>
       </p:sp>
     </p:spTree>
     <p:extLst>
       <p:ext uri="{BB962C8B-B14F-4D97-AF65-F5344CB8AC3E}">
-        <p14:creationId xmlns:p14="http://schemas.microsoft.com/office/powerpoint/2010/main" val="3765372821"/>
+        <p14:creationId xmlns:p14="http://schemas.microsoft.com/office/powerpoint/2010/main" val="3322596547"/>
       </p:ext>
     </p:extLst>
   </p:cSld>
@@ -3569,7 +3619,7 @@
 </p:sld>
 </file>
 
-<file path=ppt/slides/slide3.xml><?xml version="1.0" encoding="utf-8"?>
+<file path=ppt/slides/slide2.xml><?xml version="1.0" encoding="utf-8"?>
 <p:sld xmlns:a="http://schemas.openxmlformats.org/drawingml/2006/main" xmlns:r="http://schemas.openxmlformats.org/officeDocument/2006/relationships" xmlns:p="http://schemas.openxmlformats.org/presentationml/2006/main">
   <p:cSld>
     <p:spTree>
@@ -3651,7 +3701,7 @@
         <p:spPr>
           <a:xfrm>
             <a:off x="1209368" y="1732971"/>
-            <a:ext cx="9773264" cy="2646878"/>
+            <a:ext cx="9773264" cy="2923877"/>
           </a:xfrm>
           <a:prstGeom prst="rect">
             <a:avLst/>
@@ -3736,6 +3786,25 @@
                 <a:latin typeface="Anuphan" pitchFamily="2" charset="-34"/>
                 <a:cs typeface="Anuphan" pitchFamily="2" charset="-34"/>
               </a:rPr>
+              <a:t>Figures as Graph Objects</a:t>
+            </a:r>
+          </a:p>
+          <a:p>
+            <a:pPr marL="800100" lvl="1" indent="-342900">
+              <a:buFont typeface="Arial" panose="020B0604020202020204" pitchFamily="34" charset="0"/>
+              <a:buChar char="•"/>
+            </a:pPr>
+            <a:r>
+              <a:rPr lang="en-US" dirty="0">
+                <a:solidFill>
+                  <a:schemeClr val="tx1">
+                    <a:lumMod val="50000"/>
+                    <a:lumOff val="50000"/>
+                  </a:schemeClr>
+                </a:solidFill>
+                <a:latin typeface="Anuphan" pitchFamily="2" charset="-34"/>
+                <a:cs typeface="Anuphan" pitchFamily="2" charset="-34"/>
+              </a:rPr>
               <a:t>Plotly Express</a:t>
             </a:r>
           </a:p>
@@ -3847,6 +3916,119 @@
     <p:extLst>
       <p:ext uri="{BB962C8B-B14F-4D97-AF65-F5344CB8AC3E}">
         <p14:creationId xmlns:p14="http://schemas.microsoft.com/office/powerpoint/2010/main" val="694903440"/>
+      </p:ext>
+    </p:extLst>
+  </p:cSld>
+  <p:clrMapOvr>
+    <a:masterClrMapping/>
+  </p:clrMapOvr>
+</p:sld>
+</file>
+
+<file path=ppt/slides/slide3.xml><?xml version="1.0" encoding="utf-8"?>
+<p:sld xmlns:a="http://schemas.openxmlformats.org/drawingml/2006/main" xmlns:r="http://schemas.openxmlformats.org/officeDocument/2006/relationships" xmlns:p="http://schemas.openxmlformats.org/presentationml/2006/main">
+  <p:cSld>
+    <p:spTree>
+      <p:nvGrpSpPr>
+        <p:cNvPr id="1" name=""/>
+        <p:cNvGrpSpPr/>
+        <p:nvPr/>
+      </p:nvGrpSpPr>
+      <p:grpSpPr>
+        <a:xfrm>
+          <a:off x="0" y="0"/>
+          <a:ext cx="0" cy="0"/>
+          <a:chOff x="0" y="0"/>
+          <a:chExt cx="0" cy="0"/>
+        </a:xfrm>
+      </p:grpSpPr>
+      <p:sp>
+        <p:nvSpPr>
+          <p:cNvPr id="5" name="TextBox 4">
+            <a:extLst>
+              <a:ext uri="{FF2B5EF4-FFF2-40B4-BE49-F238E27FC236}">
+                <a16:creationId xmlns:a16="http://schemas.microsoft.com/office/drawing/2014/main" id="{D848F1C7-F8E2-FBEC-D5A9-269E330446AD}"/>
+              </a:ext>
+            </a:extLst>
+          </p:cNvPr>
+          <p:cNvSpPr txBox="1"/>
+          <p:nvPr/>
+        </p:nvSpPr>
+        <p:spPr>
+          <a:xfrm>
+            <a:off x="1052052" y="3246792"/>
+            <a:ext cx="10087896" cy="769441"/>
+          </a:xfrm>
+          <a:prstGeom prst="rect">
+            <a:avLst/>
+          </a:prstGeom>
+          <a:noFill/>
+        </p:spPr>
+        <p:txBody>
+          <a:bodyPr wrap="square">
+            <a:spAutoFit/>
+          </a:bodyPr>
+          <a:lstStyle/>
+          <a:p>
+            <a:pPr algn="l">
+              <a:buNone/>
+            </a:pPr>
+            <a:r>
+              <a:rPr lang="en-US" sz="4400" b="1" i="0" dirty="0">
+                <a:solidFill>
+                  <a:srgbClr val="20293D"/>
+                </a:solidFill>
+                <a:effectLst/>
+                <a:latin typeface="Anuphan" pitchFamily="2" charset="-34"/>
+                <a:cs typeface="Anuphan" pitchFamily="2" charset="-34"/>
+              </a:rPr>
+              <a:t>The Figure Data Structure in Python</a:t>
+            </a:r>
+          </a:p>
+        </p:txBody>
+      </p:sp>
+      <p:sp>
+        <p:nvSpPr>
+          <p:cNvPr id="7" name="TextBox 6">
+            <a:extLst>
+              <a:ext uri="{FF2B5EF4-FFF2-40B4-BE49-F238E27FC236}">
+                <a16:creationId xmlns:a16="http://schemas.microsoft.com/office/drawing/2014/main" id="{55DC4C34-2135-4DDF-F881-B2E89B36BA53}"/>
+              </a:ext>
+            </a:extLst>
+          </p:cNvPr>
+          <p:cNvSpPr txBox="1"/>
+          <p:nvPr/>
+        </p:nvSpPr>
+        <p:spPr>
+          <a:xfrm>
+            <a:off x="1052052" y="4016233"/>
+            <a:ext cx="6096000" cy="369332"/>
+          </a:xfrm>
+          <a:prstGeom prst="rect">
+            <a:avLst/>
+          </a:prstGeom>
+          <a:noFill/>
+        </p:spPr>
+        <p:txBody>
+          <a:bodyPr wrap="square">
+            <a:spAutoFit/>
+          </a:bodyPr>
+          <a:lstStyle/>
+          <a:p>
+            <a:r>
+              <a:rPr lang="en-US" dirty="0">
+                <a:hlinkClick r:id="rId2"/>
+              </a:rPr>
+              <a:t>The figure data structure in Python</a:t>
+            </a:r>
+            <a:endParaRPr lang="en-US" dirty="0"/>
+          </a:p>
+        </p:txBody>
+      </p:sp>
+    </p:spTree>
+    <p:extLst>
+      <p:ext uri="{BB962C8B-B14F-4D97-AF65-F5344CB8AC3E}">
+        <p14:creationId xmlns:p14="http://schemas.microsoft.com/office/powerpoint/2010/main" val="3765372821"/>
       </p:ext>
     </p:extLst>
   </p:cSld>

</xml_diff>